<commit_message>
docs: deck v2 with ring map, system schematic and conditions of approval
Cold open on the ban and 778 GWh, ring map on slide 4, SVG schematic on slide 5, hero 735 dollar bill cut, three-beat ask with team strip, scenario-estimate labels. Script trimmed to about 505 spoken words with a 40 s demo.
</commit_message>
<xml_diff>
--- a/docs/deck/Thermal-Commons-Heat-for-Lansing.pptx
+++ b/docs/deck/Thermal-Commons-Heat-for-Lansing.pptx
@@ -510,7 +510,7 @@
           <a:lstStyle/>
           <a:p>
             <a:r>
-              <a:t>SPEAKER: Harsh. 0:00-0:20. We are Thermal Commons. We took Site 2: TeraWulf's Lake Hawkeye data center on the old Cayuga coal plant in Lansing, NY. In five minutes: the problem, our answer, how the model works, and what it delivers for Lansing.</a:t>
+              <a:t>SPEAKER: Harsh. 0:00-0:20. Lansing's Town Board just told its attorney to draft a ban on this data center. Meanwhile 778 gigawatt-hours of heat a year goes into the air. We are Thermal Commons: Harsh Agarwal, Linson Lee, Aryaman Bhaskar, Philip Matchev. We found the conditions under which Lansing should say yes.</a:t>
             </a:r>
           </a:p>
         </p:txBody>
@@ -580,7 +580,7 @@
           <a:lstStyle/>
           <a:p>
             <a:r>
-              <a:t>SPEAKER: Harsh. 0:20-0:55. Lake Hawkeye's first 150 MW phase rejects about 778 GWh of heat a year. NYSEG has barred new gas connections there since 2015, so many homes burn propane and oil. And the Town Board has told its attorney to draft a ban. In Lansing, Michigan, Deep Green offered free heat and still withdrew in April. So our question was not how to move heat. It was: under what conditions could Lansing say yes?</a:t>
+              <a:t>SPEAKER: Harsh. 0:20-0:55. Lake Hawkeye is a proposed data center on the old Cayuga coal plant. NYSEG has barred new gas connections here since 2015, so many homes burn propane or oil. Free heat has not been enough before: Deep Green offered it to Lansing, Michigan, and withdrew in April. A promise will not carry this vote. The offer has to be binding.</a:t>
             </a:r>
           </a:p>
         </p:txBody>
@@ -650,7 +650,7 @@
           <a:lstStyle/>
           <a:p>
             <a:r>
-              <a:t>SPEAKER: Harsh. 0:55-1:25. Our answer is a deal, not just a pipe. Three conditions. One: binding contracts, a Community Benefit Agreement and a Heat Supply Agreement with step-in rights if the data center leaves. Two: the community owns the network through a thermal co-op. Three: public proof, an open dashboard. The engineering then has to make that deal pay.</a:t>
+              <a:t>SPEAKER: Harsh. 0:55-1:25. Don't ban it. Set the terms. Three conditions, written into the approval. A Community Benefit Agreement and a Heat Supply Agreement, with step-in rights if the data center leaves. A co-op that owns the pipes, so the town controls the heat. And public proof: an open dashboard every month. Cooling never depends on us, and we claim no lake water saved.</a:t>
             </a:r>
           </a:p>
         </p:txBody>
@@ -720,7 +720,7 @@
           <a:lstStyle/>
           <a:p>
             <a:r>
-              <a:t>SPEAKER: Linson. 1:25-2:05. We don't pipe the whole town. Ring one is an on-site agricultural campus, a 10-hectare greenhouse, fish farm and pool, at about 41 dollars a megawatt-hour. Ring two is 500 corridor homes on an ambient fifth-generation loop. Ring three, a town-center hot main, fails our own test at over 700 dollars, so we say not yet. Scattered homes get heat-pump rebates instead of pipe. Right tool at every density.</a:t>
+              <a:t>SPEAKER: Linson. 1:25-2:05. Density picks the tool. Ring one, on site: a greenhouse, a fish farm and a pool, 41 dollars a megawatt-hour. Ring two, down the road: 500 homes with building heat pumps, 286 dollars. Ring three, the town center, 14 kilometers out: 734 dollars. It fails our own test, so we do not build it.</a:t>
             </a:r>
           </a:p>
         </p:txBody>
@@ -790,7 +790,7 @@
           <a:lstStyle/>
           <a:p>
             <a:r>
-              <a:t>SPEAKER: Linson. 2:05-2:40. Under the hood: an hour-by-hour model for all 8,760 hours of a year on real Ithaca weather. We capture heat with a sidestream exchanger, so cooling always wins and the dry coolers keep 100 percent of their job. A central heat pump lifts it to a 55 to 65 degree loop, with efficiency computed from real temperatures every hour. Storage covers peaks. Then we price it over 30 years. It's open source with tests, and the app recalculates the economics live.</a:t>
+              <a:t>SPEAKER: Linson. 2:05-2:40. How it works. A side-stream plate exchanger sits on their sealed glycol loop. If cooling ever needs it, a bypass sends everything to the dry coolers: cooling always wins. Forty-five degree heat goes straight to the farm campus. A central heat pump lifts heat to a 65 degree loop with storage. A 20 degree ambient loop reaches 500 homes, each with its own heat pump. Variable-speed pumps move every loop. We run every one of the 8,760 hours of an Ithaca year.</a:t>
             </a:r>
           </a:p>
         </p:txBody>
@@ -860,7 +860,7 @@
           <a:lstStyle/>
           <a:p>
             <a:r>
-              <a:t>SPEAKER: Aryaman. 2:40-3:15. Base case: 50.6 gigawatt-hours of heat a year. Blended cost about 106 dollars a megawatt-hour, against 136 for propane and 156 for oil. 11,408 tonnes of CO2 avoided every year, about 2,660 cars. A corridor household saves about 735 dollars a year against propane. And we use only about 6.5 percent of the available heat, so there is room to grow.</a:t>
+              <a:t>SPEAKER: Aryaman. 2:40-3:15. Here is the number that matters. A typical propane home saves 735 dollars a year, because the tariff is 80 percent of propane. The system delivers 50.6 gigawatt-hours at a blended 106 dollars a megawatt-hour, and avoids 11,408 tonnes of carbon dioxide a year. That is 6.5 percent of the heat we can capture. The scarce thing is a signed customer.</a:t>
             </a:r>
           </a:p>
         </p:txBody>
@@ -930,7 +930,7 @@
           <a:lstStyle/>
           <a:p>
             <a:r>
-              <a:t>SPEAKER: Aryaman. 3:15-3:50. Here's the honest part. Pipe to low-density homes doesn't pay on its own, and in places an air-source heat pump is just as cheap. So the Community Benefit Agreement puts roughly 1.7 percent of the data center's capex into a fund. It pays for the corridor gap and for heat-pump rebates. We tested the downside too: if the data center exits at year 10, step-in rights and storage protect the co-op. We modeled that case.</a:t>
+              <a:t>SPEAKER: Aryaman. 3:15-3:50. The honest part. Selling below propane leaves a 26-million-dollar gap. The Community Benefit Agreement covers it with about 1.7 percent of the build. That is an estimate on an assumed 1.5-billion-dollar campus, not a disclosed budget. Federal tax credits are not in the base case. No signature, no trench.</a:t>
             </a:r>
           </a:p>
         </p:txBody>
@@ -1000,7 +1000,7 @@
           <a:lstStyle/>
           <a:p>
             <a:r>
-              <a:t>SPEAKER: Philip. 3:50-4:25. What Lansing actually gets: 500 homes off propane and oil, about 126 jobs, a year-round 10-hectare farm growing around 5,500 tonnes of food plus 1,500 tonnes of fish, and a heated community pool. We scored it against HDR's seven regenerative domains, and we stay honest about water.</a:t>
+              <a:t>SPEAKER: Philip. 3:50-4:25. What Lansing gets: 500 homes off propane and oil, a farm and a pool, and an energy reuse factor of 4.6 percent, limited by demand, not supply. Jobs and food are scenario estimates. We claim no lake water saved.</a:t>
             </a:r>
           </a:p>
         </p:txBody>
@@ -1070,7 +1070,7 @@
           <a:lstStyle/>
           <a:p>
             <a:r>
-              <a:t>SPEAKER: Philip (then Harsh runs the live demo). 4:25-5:00. Our ask to Lansing: don't ban it, set the terms. Sign the two agreements, start with the farm campus that pays for itself, and let a community co-op own the heat. Now we'll show you the live app. Thank you.</a:t>
+              <a:t>SPEAKER: Philip (then Harsh runs the live demo). 4:25-5:00. Our ask, in three beats. One: sign the Community Benefit Agreement and the Heat Supply Agreement before site approval. No one has signed yet. Two: about 1.7 percent of the build, an estimate. Three: a 735-dollar cut to a propane bill. Don't ban it. Set the terms. Harsh, the model.</a:t>
             </a:r>
           </a:p>
         </p:txBody>

</xml_diff>

<commit_message>
chore: update team to three members; Harsh presents results and funding
</commit_message>
<xml_diff>
--- a/docs/deck/Thermal-Commons-Heat-for-Lansing.pptx
+++ b/docs/deck/Thermal-Commons-Heat-for-Lansing.pptx
@@ -510,7 +510,7 @@
           <a:lstStyle/>
           <a:p>
             <a:r>
-              <a:t>SPEAKER: Harsh. 0:00-0:20. Lansing's Town Board just told its attorney to draft a ban on this data center. Meanwhile 778 gigawatt-hours of heat a year goes into the air. We are Thermal Commons: Harsh Agarwal, Linson Lee, Aryaman Bhaskar, Philip Matchev. We found the conditions under which Lansing should say yes.</a:t>
+              <a:t>SPEAKER: Harsh. 0:00-0:20. Lansing's Town Board just told its attorney to draft a ban on this data center. Meanwhile 778 gigawatt-hours of heat a year goes into the air. We are Thermal Commons: Harsh Agarwal, Linson Lee, Philip Matchev. We found the conditions under which Lansing should say yes.</a:t>
             </a:r>
           </a:p>
         </p:txBody>
@@ -860,7 +860,7 @@
           <a:lstStyle/>
           <a:p>
             <a:r>
-              <a:t>SPEAKER: Aryaman. 2:40-3:15. Here is the number that matters. A typical propane home saves 735 dollars a year, because the tariff is 80 percent of propane. The system delivers 50.6 gigawatt-hours at a blended 106 dollars a megawatt-hour, and avoids 11,408 tonnes of carbon dioxide a year. That is 6.5 percent of the heat we can capture. The scarce thing is a signed customer.</a:t>
+              <a:t>SPEAKER: Harsh. 2:40-3:15. Here is the number that matters. A typical propane home saves 735 dollars a year, because the tariff is 80 percent of propane. The system delivers 50.6 gigawatt-hours at a blended 106 dollars a megawatt-hour, and avoids 11,408 tonnes of carbon dioxide a year. That is 6.5 percent of the heat we can capture. The scarce thing is a signed customer.</a:t>
             </a:r>
           </a:p>
         </p:txBody>
@@ -930,7 +930,7 @@
           <a:lstStyle/>
           <a:p>
             <a:r>
-              <a:t>SPEAKER: Aryaman. 3:15-3:50. The honest part. Selling below propane leaves a 26-million-dollar gap. The Community Benefit Agreement covers it with about 1.7 percent of the build. That is an estimate on an assumed 1.5-billion-dollar campus, not a disclosed budget. Federal tax credits are not in the base case. No signature, no trench.</a:t>
+              <a:t>SPEAKER: Harsh. 3:15-3:50. The honest part. Selling below propane leaves a 26-million-dollar gap. The Community Benefit Agreement covers it with about 1.7 percent of the build. That is an estimate on an assumed 1.5-billion-dollar campus, not a disclosed budget. Federal tax credits are not in the base case. No signature, no trench.</a:t>
             </a:r>
           </a:p>
         </p:txBody>

</xml_diff>

<commit_message>
chore: update team to three members; Harsh presents results and funding (#27)
</commit_message>
<xml_diff>
--- a/docs/deck/Thermal-Commons-Heat-for-Lansing.pptx
+++ b/docs/deck/Thermal-Commons-Heat-for-Lansing.pptx
@@ -510,7 +510,7 @@
           <a:lstStyle/>
           <a:p>
             <a:r>
-              <a:t>SPEAKER: Harsh. 0:00-0:20. Lansing's Town Board just told its attorney to draft a ban on this data center. Meanwhile 778 gigawatt-hours of heat a year goes into the air. We are Thermal Commons: Harsh Agarwal, Linson Lee, Aryaman Bhaskar, Philip Matchev. We found the conditions under which Lansing should say yes.</a:t>
+              <a:t>SPEAKER: Harsh. 0:00-0:20. Lansing's Town Board just told its attorney to draft a ban on this data center. Meanwhile 778 gigawatt-hours of heat a year goes into the air. We are Thermal Commons: Harsh Agarwal, Linson Lee, Philip Matchev. We found the conditions under which Lansing should say yes.</a:t>
             </a:r>
           </a:p>
         </p:txBody>
@@ -860,7 +860,7 @@
           <a:lstStyle/>
           <a:p>
             <a:r>
-              <a:t>SPEAKER: Aryaman. 2:40-3:15. Here is the number that matters. A typical propane home saves 735 dollars a year, because the tariff is 80 percent of propane. The system delivers 50.6 gigawatt-hours at a blended 106 dollars a megawatt-hour, and avoids 11,408 tonnes of carbon dioxide a year. That is 6.5 percent of the heat we can capture. The scarce thing is a signed customer.</a:t>
+              <a:t>SPEAKER: Harsh. 2:40-3:15. Here is the number that matters. A typical propane home saves 735 dollars a year, because the tariff is 80 percent of propane. The system delivers 50.6 gigawatt-hours at a blended 106 dollars a megawatt-hour, and avoids 11,408 tonnes of carbon dioxide a year. That is 6.5 percent of the heat we can capture. The scarce thing is a signed customer.</a:t>
             </a:r>
           </a:p>
         </p:txBody>
@@ -930,7 +930,7 @@
           <a:lstStyle/>
           <a:p>
             <a:r>
-              <a:t>SPEAKER: Aryaman. 3:15-3:50. The honest part. Selling below propane leaves a 26-million-dollar gap. The Community Benefit Agreement covers it with about 1.7 percent of the build. That is an estimate on an assumed 1.5-billion-dollar campus, not a disclosed budget. Federal tax credits are not in the base case. No signature, no trench.</a:t>
+              <a:t>SPEAKER: Harsh. 3:15-3:50. The honest part. Selling below propane leaves a 26-million-dollar gap. The Community Benefit Agreement covers it with about 1.7 percent of the build. That is an estimate on an assumed 1.5-billion-dollar campus, not a disclosed budget. Federal tax credits are not in the base case. No signature, no trench.</a:t>
             </a:r>
           </a:p>
         </p:txBody>

</xml_diff>

<commit_message>
fix: imperial one-pager and deck, keep page content above header swash
</commit_message>
<xml_diff>
--- a/docs/deck/Thermal-Commons-Heat-for-Lansing.pptx
+++ b/docs/deck/Thermal-Commons-Heat-for-Lansing.pptx
@@ -720,7 +720,7 @@
           <a:lstStyle/>
           <a:p>
             <a:r>
-              <a:t>SPEAKER: Linson. 1:25-2:05. Density picks the tool. Ring one, on site: a greenhouse, a fish farm and a pool, 41 dollars a megawatt-hour. Ring two, down the road: 500 homes with building heat pumps, 286 dollars. Ring three, the town center, 14 kilometers out: 734 dollars. It fails our own test, so we do not build it.</a:t>
+              <a:t>SPEAKER: Linson. 1:25-2:05. Density picks the tool. Ring one, on site: a greenhouse, a fish farm and a pool, 41 dollars a megawatt-hour. Ring two, down the road: 500 homes with building heat pumps, 286 dollars. Ring three, the town center, 8.7 miles out: 734 dollars. It fails our own test, so we do not build it.</a:t>
             </a:r>
           </a:p>
         </p:txBody>
@@ -790,7 +790,7 @@
           <a:lstStyle/>
           <a:p>
             <a:r>
-              <a:t>SPEAKER: Linson. 2:05-2:40. How it works. A side-stream plate exchanger sits on their sealed glycol loop. If cooling ever needs it, a bypass sends everything to the dry coolers: cooling always wins. Forty-five degree heat goes straight to the farm campus. A central heat pump lifts heat to a 65 degree loop with storage. A 20 degree ambient loop reaches 500 homes, each with its own heat pump. Variable-speed pumps move every loop. We run every one of the 8,760 hours of an Ithaca year.</a:t>
+              <a:t>SPEAKER: Linson. 2:05-2:40. How it works. A side-stream plate exchanger sits on their sealed glycol loop. If cooling ever needs it, a bypass sends everything to the dry coolers: cooling always wins. One hundred thirteen degree heat goes straight to the farm campus. A central heat pump lifts heat to a 149 degree loop with storage. A 68 degree ambient loop reaches 500 homes, each with its own heat pump. Variable-speed pumps move every loop. We run every one of the 8,760 hours of an Ithaca year.</a:t>
             </a:r>
           </a:p>
         </p:txBody>
@@ -860,7 +860,7 @@
           <a:lstStyle/>
           <a:p>
             <a:r>
-              <a:t>SPEAKER: Harsh. 2:40-3:15. Here is the number that matters. A typical propane home saves 735 dollars a year, because the tariff is 80 percent of propane. The system delivers 50.6 gigawatt-hours at a blended 106 dollars a megawatt-hour, and avoids 11,408 tonnes of carbon dioxide a year. That is 6.5 percent of the heat we can capture. The scarce thing is a signed customer.</a:t>
+              <a:t>SPEAKER: Harsh. 2:40-3:15. Here is the number that matters. A typical propane home saves 735 dollars a year, because the tariff is 80 percent of propane. The system delivers 50.6 gigawatt-hours at a blended 106 dollars a megawatt-hour, and avoids 12,575 short tons of carbon dioxide a year. That is 6.5 percent of the heat we can capture. The scarce thing is a signed customer.</a:t>
             </a:r>
           </a:p>
         </p:txBody>

</xml_diff>

<commit_message>
feat: imperial units, nicer Explore and Compare pages (#29)
* feat: add live figures, icons and grouped controls to Explore

* feat: show US imperial units across site and docs

* feat: add hero, site cards and paired bars to Compare

* fix: address CodeRabbit review on PR 29 (negative C, t/yr, Pa/m factor, doc figures)

* fix: imperial one-pager and deck, keep page content above header swash
</commit_message>
<xml_diff>
--- a/docs/deck/Thermal-Commons-Heat-for-Lansing.pptx
+++ b/docs/deck/Thermal-Commons-Heat-for-Lansing.pptx
@@ -720,7 +720,7 @@
           <a:lstStyle/>
           <a:p>
             <a:r>
-              <a:t>SPEAKER: Linson. 1:25-2:05. Density picks the tool. Ring one, on site: a greenhouse, a fish farm and a pool, 41 dollars a megawatt-hour. Ring two, down the road: 500 homes with building heat pumps, 286 dollars. Ring three, the town center, 14 kilometers out: 734 dollars. It fails our own test, so we do not build it.</a:t>
+              <a:t>SPEAKER: Linson. 1:25-2:05. Density picks the tool. Ring one, on site: a greenhouse, a fish farm and a pool, 41 dollars a megawatt-hour. Ring two, down the road: 500 homes with building heat pumps, 286 dollars. Ring three, the town center, 8.7 miles out: 734 dollars. It fails our own test, so we do not build it.</a:t>
             </a:r>
           </a:p>
         </p:txBody>
@@ -790,7 +790,7 @@
           <a:lstStyle/>
           <a:p>
             <a:r>
-              <a:t>SPEAKER: Linson. 2:05-2:40. How it works. A side-stream plate exchanger sits on their sealed glycol loop. If cooling ever needs it, a bypass sends everything to the dry coolers: cooling always wins. Forty-five degree heat goes straight to the farm campus. A central heat pump lifts heat to a 65 degree loop with storage. A 20 degree ambient loop reaches 500 homes, each with its own heat pump. Variable-speed pumps move every loop. We run every one of the 8,760 hours of an Ithaca year.</a:t>
+              <a:t>SPEAKER: Linson. 2:05-2:40. How it works. A side-stream plate exchanger sits on their sealed glycol loop. If cooling ever needs it, a bypass sends everything to the dry coolers: cooling always wins. One hundred thirteen degree heat goes straight to the farm campus. A central heat pump lifts heat to a 149 degree loop with storage. A 68 degree ambient loop reaches 500 homes, each with its own heat pump. Variable-speed pumps move every loop. We run every one of the 8,760 hours of an Ithaca year.</a:t>
             </a:r>
           </a:p>
         </p:txBody>
@@ -860,7 +860,7 @@
           <a:lstStyle/>
           <a:p>
             <a:r>
-              <a:t>SPEAKER: Harsh. 2:40-3:15. Here is the number that matters. A typical propane home saves 735 dollars a year, because the tariff is 80 percent of propane. The system delivers 50.6 gigawatt-hours at a blended 106 dollars a megawatt-hour, and avoids 11,408 tonnes of carbon dioxide a year. That is 6.5 percent of the heat we can capture. The scarce thing is a signed customer.</a:t>
+              <a:t>SPEAKER: Harsh. 2:40-3:15. Here is the number that matters. A typical propane home saves 735 dollars a year, because the tariff is 80 percent of propane. The system delivers 50.6 gigawatt-hours at a blended 106 dollars a megawatt-hour, and avoids 12,575 short tons of carbon dioxide a year. That is 6.5 percent of the heat we can capture. The scarce thing is a signed customer.</a:t>
             </a:r>
           </a:p>
         </p:txBody>

</xml_diff>